<commit_message>
Name every symbol by its physics meaning in slides and script
m is the magnetisation (average opinion), J the coupling, beta the inverse
temperature, h the external field, X the observable, alpha the coupling
constant, h_c the critical field, beta J the reduced coupling, Delta X the
spread. The script says the name and the meaning, never the bare letter.
</commit_message>
<xml_diff>
--- a/docs/defence/Monarch_Supervisor_Deck.pptx
+++ b/docs/defence/Monarch_Supervisor_Deck.pptx
@@ -8622,7 +8622,7 @@
       </p:pic>
       <p:pic>
         <p:nvPicPr>
-          <p:cNvPr id="9" name="Picture 8" descr="5272f2755a3e4bf7.png"/>
+          <p:cNvPr id="9" name="Picture 8" descr="20c93cf97540e448.png"/>
           <p:cNvPicPr>
             <a:picLocks noChangeAspect="1"/>
           </p:cNvPicPr>
@@ -8636,8 +8636,8 @@
         </p:blipFill>
         <p:spPr>
           <a:xfrm>
-            <a:off x="1230325" y="2743200"/>
-            <a:ext cx="191109" cy="286664"/>
+            <a:off x="1181290" y="2542032"/>
+            <a:ext cx="152019" cy="247573"/>
           </a:xfrm>
           <a:prstGeom prst="rect">
             <a:avLst/>
@@ -8652,8 +8652,8 @@
         </p:nvSpPr>
         <p:spPr>
           <a:xfrm>
-            <a:off x="1920240" y="2697480"/>
-            <a:ext cx="3840480" cy="548640"/>
+            <a:off x="1783080" y="2487168"/>
+            <a:ext cx="4023360" cy="502920"/>
           </a:xfrm>
           <a:prstGeom prst="rect">
             <a:avLst/>
@@ -8672,20 +8672,29 @@
               </a:spcAft>
             </a:pPr>
             <a:r>
-              <a:rPr sz="1500" b="0" i="0">
+              <a:rPr sz="1300" b="1">
+                <a:solidFill>
+                  <a:srgbClr val="7CC4FF"/>
+                </a:solidFill>
+                <a:latin typeface="Calibri"/>
+              </a:rPr>
+              <a:t>external field  </a:t>
+            </a:r>
+            <a:r>
+              <a:rPr sz="1300" b="0">
                 <a:solidFill>
                   <a:srgbClr val="EEF3FA"/>
                 </a:solidFill>
                 <a:latin typeface="Calibri"/>
               </a:rPr>
-              <a:t>strength of the push per unit of score</a:t>
+              <a:t>= media's push on everyone</a:t>
             </a:r>
           </a:p>
         </p:txBody>
       </p:sp>
       <p:pic>
         <p:nvPicPr>
-          <p:cNvPr id="11" name="Picture 10" descr="3083b7f6cdc240b3.png"/>
+          <p:cNvPr id="11" name="Picture 10" descr="a2dd4f017e3f8d43.png"/>
           <p:cNvPicPr>
             <a:picLocks noChangeAspect="1"/>
           </p:cNvPicPr>
@@ -8699,8 +8708,8 @@
         </p:blipFill>
         <p:spPr>
           <a:xfrm>
-            <a:off x="1191348" y="3429000"/>
-            <a:ext cx="269062" cy="286664"/>
+            <a:off x="1144371" y="3063240"/>
+            <a:ext cx="225856" cy="247573"/>
           </a:xfrm>
           <a:prstGeom prst="rect">
             <a:avLst/>
@@ -8715,8 +8724,8 @@
         </p:nvSpPr>
         <p:spPr>
           <a:xfrm>
-            <a:off x="1920240" y="3383280"/>
-            <a:ext cx="3840480" cy="548640"/>
+            <a:off x="1783080" y="3008376"/>
+            <a:ext cx="4023360" cy="502920"/>
           </a:xfrm>
           <a:prstGeom prst="rect">
             <a:avLst/>
@@ -8735,20 +8744,29 @@
               </a:spcAft>
             </a:pPr>
             <a:r>
-              <a:rPr sz="1500" b="0" i="0">
+              <a:rPr sz="1300" b="1">
+                <a:solidFill>
+                  <a:srgbClr val="7CC4FF"/>
+                </a:solidFill>
+                <a:latin typeface="Calibri"/>
+              </a:rPr>
+              <a:t>observable  </a:t>
+            </a:r>
+            <a:r>
+              <a:rPr sz="1300" b="0">
                 <a:solidFill>
                   <a:srgbClr val="EEF3FA"/>
                 </a:solidFill>
                 <a:latin typeface="Calibri"/>
               </a:rPr>
-              <a:t>smallest push that flips the majority</a:t>
+              <a:t>= our score for an article</a:t>
             </a:r>
           </a:p>
         </p:txBody>
       </p:sp>
       <p:pic>
         <p:nvPicPr>
-          <p:cNvPr id="13" name="Picture 12" descr="92db4915de0152da.png"/>
+          <p:cNvPr id="13" name="Picture 12" descr="5272f2755a3e4bf7.png"/>
           <p:cNvPicPr>
             <a:picLocks noChangeAspect="1"/>
           </p:cNvPicPr>
@@ -8762,8 +8780,8 @@
         </p:blipFill>
         <p:spPr>
           <a:xfrm>
-            <a:off x="1146086" y="4114800"/>
-            <a:ext cx="359587" cy="289179"/>
+            <a:off x="1174775" y="3584448"/>
+            <a:ext cx="165049" cy="247573"/>
           </a:xfrm>
           <a:prstGeom prst="rect">
             <a:avLst/>
@@ -8778,8 +8796,8 @@
         </p:nvSpPr>
         <p:spPr>
           <a:xfrm>
-            <a:off x="1920240" y="4069080"/>
-            <a:ext cx="3840480" cy="548640"/>
+            <a:off x="1783080" y="3529584"/>
+            <a:ext cx="4023360" cy="502920"/>
           </a:xfrm>
           <a:prstGeom prst="rect">
             <a:avLst/>
@@ -8798,20 +8816,29 @@
               </a:spcAft>
             </a:pPr>
             <a:r>
-              <a:rPr sz="1500" b="0" i="0">
+              <a:rPr sz="1300" b="1">
+                <a:solidFill>
+                  <a:srgbClr val="7CC4FF"/>
+                </a:solidFill>
+                <a:latin typeface="Calibri"/>
+              </a:rPr>
+              <a:t>coupling constant  </a:t>
+            </a:r>
+            <a:r>
+              <a:rPr sz="1300" b="0">
                 <a:solidFill>
                   <a:srgbClr val="EEF3FA"/>
                 </a:solidFill>
                 <a:latin typeface="Calibri"/>
               </a:rPr>
-              <a:t>how strongly people copy each other</a:t>
+              <a:t>= push per unit of score</a:t>
             </a:r>
           </a:p>
         </p:txBody>
       </p:sp>
       <p:pic>
         <p:nvPicPr>
-          <p:cNvPr id="15" name="Picture 14" descr="4b880f26890debb7.png"/>
+          <p:cNvPr id="15" name="Picture 14" descr="3083b7f6cdc240b3.png"/>
           <p:cNvPicPr>
             <a:picLocks noChangeAspect="1"/>
           </p:cNvPicPr>
@@ -8825,8 +8852,8 @@
         </p:blipFill>
         <p:spPr>
           <a:xfrm>
-            <a:off x="1078191" y="4800600"/>
-            <a:ext cx="495376" cy="286664"/>
+            <a:off x="1141114" y="4105655"/>
+            <a:ext cx="232371" cy="247573"/>
           </a:xfrm>
           <a:prstGeom prst="rect">
             <a:avLst/>
@@ -8841,8 +8868,8 @@
         </p:nvSpPr>
         <p:spPr>
           <a:xfrm>
-            <a:off x="1920240" y="4754880"/>
-            <a:ext cx="3840480" cy="548640"/>
+            <a:off x="1783080" y="4050791"/>
+            <a:ext cx="4023360" cy="502920"/>
           </a:xfrm>
           <a:prstGeom prst="rect">
             <a:avLst/>
@@ -8861,20 +8888,173 @@
               </a:spcAft>
             </a:pPr>
             <a:r>
-              <a:rPr sz="1500" b="0" i="0">
+              <a:rPr sz="1300" b="1">
+                <a:solidFill>
+                  <a:srgbClr val="7CC4FF"/>
+                </a:solidFill>
+                <a:latin typeface="Calibri"/>
+              </a:rPr>
+              <a:t>critical field  </a:t>
+            </a:r>
+            <a:r>
+              <a:rPr sz="1300" b="0">
                 <a:solidFill>
                   <a:srgbClr val="EEF3FA"/>
                 </a:solidFill>
                 <a:latin typeface="Calibri"/>
               </a:rPr>
-              <a:t>spread of our scores = 0.124</a:t>
+              <a:t>= smallest push that flips the majority</a:t>
+            </a:r>
+          </a:p>
+        </p:txBody>
+      </p:sp>
+      <p:pic>
+        <p:nvPicPr>
+          <p:cNvPr id="17" name="Picture 16" descr="92db4915de0152da.png"/>
+          <p:cNvPicPr>
+            <a:picLocks noChangeAspect="1"/>
+          </p:cNvPicPr>
+          <p:nvPr/>
+        </p:nvPicPr>
+        <p:blipFill>
+          <a:blip r:embed="rId8"/>
+          <a:stretch>
+            <a:fillRect/>
+          </a:stretch>
+        </p:blipFill>
+        <p:spPr>
+          <a:xfrm>
+            <a:off x="1102023" y="4626864"/>
+            <a:ext cx="310553" cy="249745"/>
+          </a:xfrm>
+          <a:prstGeom prst="rect">
+            <a:avLst/>
+          </a:prstGeom>
+        </p:spPr>
+      </p:pic>
+      <p:sp>
+        <p:nvSpPr>
+          <p:cNvPr id="18" name="TextBox 17"/>
+          <p:cNvSpPr txBox="1"/>
+          <p:nvPr/>
+        </p:nvSpPr>
+        <p:spPr>
+          <a:xfrm>
+            <a:off x="1783080" y="4572000"/>
+            <a:ext cx="4023360" cy="502920"/>
+          </a:xfrm>
+          <a:prstGeom prst="rect">
+            <a:avLst/>
+          </a:prstGeom>
+          <a:noFill/>
+        </p:spPr>
+        <p:txBody>
+          <a:bodyPr wrap="square" anchor="ctr">
+            <a:spAutoFit/>
+          </a:bodyPr>
+          <a:lstStyle/>
+          <a:p>
+            <a:pPr algn="l">
+              <a:spcAft>
+                <a:spcPts val="0"/>
+              </a:spcAft>
+            </a:pPr>
+            <a:r>
+              <a:rPr sz="1300" b="1">
+                <a:solidFill>
+                  <a:srgbClr val="7CC4FF"/>
+                </a:solidFill>
+                <a:latin typeface="Calibri"/>
+              </a:rPr>
+              <a:t>reduced coupling  </a:t>
+            </a:r>
+            <a:r>
+              <a:rPr sz="1300" b="0">
+                <a:solidFill>
+                  <a:srgbClr val="EEF3FA"/>
+                </a:solidFill>
+                <a:latin typeface="Calibri"/>
+              </a:rPr>
+              <a:t>= how strongly people copy each other</a:t>
+            </a:r>
+          </a:p>
+        </p:txBody>
+      </p:sp>
+      <p:pic>
+        <p:nvPicPr>
+          <p:cNvPr id="19" name="Picture 18" descr="4b880f26890debb7.png"/>
+          <p:cNvPicPr>
+            <a:picLocks noChangeAspect="1"/>
+          </p:cNvPicPr>
+          <p:nvPr/>
+        </p:nvPicPr>
+        <p:blipFill>
+          <a:blip r:embed="rId9"/>
+          <a:stretch>
+            <a:fillRect/>
+          </a:stretch>
+        </p:blipFill>
+        <p:spPr>
+          <a:xfrm>
+            <a:off x="1043387" y="5148072"/>
+            <a:ext cx="427824" cy="247573"/>
+          </a:xfrm>
+          <a:prstGeom prst="rect">
+            <a:avLst/>
+          </a:prstGeom>
+        </p:spPr>
+      </p:pic>
+      <p:sp>
+        <p:nvSpPr>
+          <p:cNvPr id="20" name="TextBox 19"/>
+          <p:cNvSpPr txBox="1"/>
+          <p:nvPr/>
+        </p:nvSpPr>
+        <p:spPr>
+          <a:xfrm>
+            <a:off x="1783080" y="5093208"/>
+            <a:ext cx="4023360" cy="502920"/>
+          </a:xfrm>
+          <a:prstGeom prst="rect">
+            <a:avLst/>
+          </a:prstGeom>
+          <a:noFill/>
+        </p:spPr>
+        <p:txBody>
+          <a:bodyPr wrap="square" anchor="ctr">
+            <a:spAutoFit/>
+          </a:bodyPr>
+          <a:lstStyle/>
+          <a:p>
+            <a:pPr algn="l">
+              <a:spcAft>
+                <a:spcPts val="0"/>
+              </a:spcAft>
+            </a:pPr>
+            <a:r>
+              <a:rPr sz="1300" b="1">
+                <a:solidFill>
+                  <a:srgbClr val="7CC4FF"/>
+                </a:solidFill>
+                <a:latin typeface="Calibri"/>
+              </a:rPr>
+              <a:t>spread  </a:t>
+            </a:r>
+            <a:r>
+              <a:rPr sz="1300" b="0">
+                <a:solidFill>
+                  <a:srgbClr val="EEF3FA"/>
+                </a:solidFill>
+                <a:latin typeface="Calibri"/>
+              </a:rPr>
+              <a:t>= range of our scores = 0.124</a:t>
             </a:r>
           </a:p>
         </p:txBody>
       </p:sp>
       <p:graphicFrame>
         <p:nvGraphicFramePr>
-          <p:cNvPr id="17" name="Chart 16"/>
+          <p:cNvPr id="21" name="Chart 20"/>
           <p:cNvGraphicFramePr>
             <a:graphicFrameLocks noGrp="1"/>
           </p:cNvGraphicFramePr>
@@ -8886,13 +9066,13 @@
         </p:xfrm>
         <a:graphic>
           <a:graphicData uri="http://schemas.openxmlformats.org/drawingml/2006/chart">
-            <c:chart xmlns:c="http://schemas.openxmlformats.org/drawingml/2006/chart" r:id="rId8"/>
+            <c:chart xmlns:c="http://schemas.openxmlformats.org/drawingml/2006/chart" r:id="rId10"/>
           </a:graphicData>
         </a:graphic>
       </p:graphicFrame>
       <p:sp>
         <p:nvSpPr>
-          <p:cNvPr id="18" name="TextBox 17"/>
+          <p:cNvPr id="22" name="TextBox 21"/>
           <p:cNvSpPr txBox="1"/>
           <p:nvPr/>
         </p:nvSpPr>
@@ -8931,7 +9111,7 @@
       </p:sp>
       <p:sp>
         <p:nvSpPr>
-          <p:cNvPr id="19" name="TextBox 18"/>
+          <p:cNvPr id="23" name="TextBox 22"/>
           <p:cNvSpPr txBox="1"/>
           <p:nvPr/>
         </p:nvSpPr>
@@ -8970,7 +9150,7 @@
       </p:sp>
       <p:sp>
         <p:nvSpPr>
-          <p:cNvPr id="20" name="Rounded Rectangle 19"/>
+          <p:cNvPr id="24" name="Rounded Rectangle 23"/>
           <p:cNvSpPr/>
           <p:nvPr/>
         </p:nvSpPr>
@@ -9047,7 +9227,7 @@
       </p:sp>
       <p:sp>
         <p:nvSpPr>
-          <p:cNvPr id="21" name="TextBox 20"/>
+          <p:cNvPr id="25" name="TextBox 24"/>
           <p:cNvSpPr txBox="1"/>
           <p:nvPr/>
         </p:nvSpPr>
@@ -9086,7 +9266,7 @@
       </p:sp>
       <p:sp>
         <p:nvSpPr>
-          <p:cNvPr id="22" name="Rectangle 21"/>
+          <p:cNvPr id="26" name="Rectangle 25"/>
           <p:cNvSpPr/>
           <p:nvPr/>
         </p:nvSpPr>
@@ -9130,7 +9310,7 @@
       </p:sp>
       <p:sp>
         <p:nvSpPr>
-          <p:cNvPr id="23" name="Rectangle 22"/>
+          <p:cNvPr id="27" name="Rectangle 26"/>
           <p:cNvSpPr/>
           <p:nvPr/>
         </p:nvSpPr>
@@ -9174,7 +9354,7 @@
       </p:sp>
       <p:sp>
         <p:nvSpPr>
-          <p:cNvPr id="24" name="Rectangle 23"/>
+          <p:cNvPr id="28" name="Rectangle 27"/>
           <p:cNvSpPr/>
           <p:nvPr/>
         </p:nvSpPr>
@@ -9218,7 +9398,7 @@
       </p:sp>
       <p:sp>
         <p:nvSpPr>
-          <p:cNvPr id="25" name="Rectangle 24"/>
+          <p:cNvPr id="29" name="Rectangle 28"/>
           <p:cNvSpPr/>
           <p:nvPr/>
         </p:nvSpPr>
@@ -9262,7 +9442,7 @@
       </p:sp>
       <p:sp>
         <p:nvSpPr>
-          <p:cNvPr id="26" name="Rectangle 25"/>
+          <p:cNvPr id="30" name="Rectangle 29"/>
           <p:cNvSpPr/>
           <p:nvPr/>
         </p:nvSpPr>
@@ -9308,7 +9488,7 @@
       </p:sp>
       <p:sp>
         <p:nvSpPr>
-          <p:cNvPr id="27" name="TextBox 26"/>
+          <p:cNvPr id="31" name="TextBox 30"/>
           <p:cNvSpPr txBox="1"/>
           <p:nvPr/>
         </p:nvSpPr>
@@ -15727,8 +15907,8 @@
                 </a:solidFill>
                 <a:latin typeface="Calibri"/>
               </a:rPr>
-              <a:t>average opinion
-−1 all against · +1 all for</a:t>
+              <a:t>magnetisation
+= average opinion, −1 to +1</a:t>
             </a:r>
           </a:p>
         </p:txBody>
@@ -15839,8 +16019,8 @@
                 </a:solidFill>
                 <a:latin typeface="Calibri"/>
               </a:rPr>
-              <a:t>pull toward
-the people around you</a:t>
+              <a:t>coupling
+= pull toward neighbours</a:t>
             </a:r>
           </a:p>
         </p:txBody>
@@ -15951,8 +16131,8 @@
                 </a:solidFill>
                 <a:latin typeface="Calibri"/>
               </a:rPr>
-              <a:t>how firmly people
-follow that pull</a:t>
+              <a:t>inverse temperature
+= how firmly people follow</a:t>
             </a:r>
           </a:p>
         </p:txBody>
@@ -16063,8 +16243,8 @@
                 </a:solidFill>
                 <a:latin typeface="Calibri"/>
               </a:rPr>
-              <a:t>media's push,
-the same on everyone</a:t>
+              <a:t>external field
+= media's push on everyone</a:t>
             </a:r>
           </a:p>
         </p:txBody>

</xml_diff>

<commit_message>
Show the live instrument on the method slide, add definitions to notes
Slide 4 carries a screenshot of the published instrument (the corpus's
highest-scoring article) and a clickable link card. Every slide's notes
gain a definitions block for follow-up questions, and the Kenyan-data
question is answered on slides 5 and 14.
</commit_message>
<xml_diff>
--- a/docs/defence/Monarch_Supervisor_Deck.pptx
+++ b/docs/defence/Monarch_Supervisor_Deck.pptx
@@ -13235,7 +13235,7 @@
                 </a:solidFill>
                 <a:latin typeface="Calibri"/>
               </a:rPr>
-              <a:t>Kenya: 2024 Finance Bill coverage</a:t>
+              <a:t>Kenya: 2024 Finance Bill (funding)</a:t>
             </a:r>
           </a:p>
         </p:txBody>
@@ -20339,7 +20339,7 @@
         <p:spPr>
           <a:xfrm>
             <a:off x="685800" y="1325880"/>
-            <a:ext cx="1938528" cy="1371600"/>
+            <a:ext cx="1938528" cy="1188720"/>
           </a:xfrm>
           <a:prstGeom prst="roundRect">
             <a:avLst>
@@ -20394,8 +20394,8 @@
         </p:blipFill>
         <p:spPr>
           <a:xfrm>
-            <a:off x="1453896" y="1463040"/>
-            <a:ext cx="402336" cy="402336"/>
+            <a:off x="1472184" y="1417320"/>
+            <a:ext cx="365760" cy="365760"/>
           </a:xfrm>
           <a:prstGeom prst="rect">
             <a:avLst/>
@@ -20410,8 +20410,8 @@
         </p:nvSpPr>
         <p:spPr>
           <a:xfrm>
-            <a:off x="685800" y="1920240"/>
-            <a:ext cx="1938528" cy="731520"/>
+            <a:off x="685800" y="1810512"/>
+            <a:ext cx="1938528" cy="685800"/>
           </a:xfrm>
           <a:prstGeom prst="rect">
             <a:avLst/>
@@ -20465,7 +20465,7 @@
         </p:nvSpPr>
         <p:spPr>
           <a:xfrm>
-            <a:off x="2670048" y="1938528"/>
+            <a:off x="2670048" y="1847088"/>
             <a:ext cx="192024" cy="146304"/>
           </a:xfrm>
           <a:prstGeom prst="rightArrow">
@@ -20510,7 +20510,7 @@
         <p:spPr>
           <a:xfrm>
             <a:off x="2907792" y="1325880"/>
-            <a:ext cx="1938528" cy="1371600"/>
+            <a:ext cx="1938528" cy="1188720"/>
           </a:xfrm>
           <a:prstGeom prst="roundRect">
             <a:avLst>
@@ -20565,8 +20565,8 @@
         </p:blipFill>
         <p:spPr>
           <a:xfrm>
-            <a:off x="3675888" y="1463040"/>
-            <a:ext cx="402336" cy="402336"/>
+            <a:off x="3694176" y="1417320"/>
+            <a:ext cx="365760" cy="365760"/>
           </a:xfrm>
           <a:prstGeom prst="rect">
             <a:avLst/>
@@ -20581,8 +20581,8 @@
         </p:nvSpPr>
         <p:spPr>
           <a:xfrm>
-            <a:off x="2907792" y="1920240"/>
-            <a:ext cx="1938528" cy="731520"/>
+            <a:off x="2907792" y="1810512"/>
+            <a:ext cx="1938528" cy="685800"/>
           </a:xfrm>
           <a:prstGeom prst="rect">
             <a:avLst/>
@@ -20636,7 +20636,7 @@
         </p:nvSpPr>
         <p:spPr>
           <a:xfrm>
-            <a:off x="4892040" y="1938528"/>
+            <a:off x="4892040" y="1847088"/>
             <a:ext cx="192024" cy="146304"/>
           </a:xfrm>
           <a:prstGeom prst="rightArrow">
@@ -20681,7 +20681,7 @@
         <p:spPr>
           <a:xfrm>
             <a:off x="5129784" y="1325880"/>
-            <a:ext cx="1938528" cy="1371600"/>
+            <a:ext cx="1938528" cy="1188720"/>
           </a:xfrm>
           <a:prstGeom prst="roundRect">
             <a:avLst>
@@ -20736,8 +20736,8 @@
         </p:blipFill>
         <p:spPr>
           <a:xfrm>
-            <a:off x="5897880" y="1463040"/>
-            <a:ext cx="402336" cy="402336"/>
+            <a:off x="5916168" y="1417320"/>
+            <a:ext cx="365760" cy="365760"/>
           </a:xfrm>
           <a:prstGeom prst="rect">
             <a:avLst/>
@@ -20752,8 +20752,8 @@
         </p:nvSpPr>
         <p:spPr>
           <a:xfrm>
-            <a:off x="5129784" y="1920240"/>
-            <a:ext cx="1938528" cy="731520"/>
+            <a:off x="5129784" y="1810512"/>
+            <a:ext cx="1938528" cy="685800"/>
           </a:xfrm>
           <a:prstGeom prst="rect">
             <a:avLst/>
@@ -20807,7 +20807,7 @@
         </p:nvSpPr>
         <p:spPr>
           <a:xfrm>
-            <a:off x="7114032" y="1938528"/>
+            <a:off x="7114032" y="1847088"/>
             <a:ext cx="192024" cy="146304"/>
           </a:xfrm>
           <a:prstGeom prst="rightArrow">
@@ -20852,7 +20852,7 @@
         <p:spPr>
           <a:xfrm>
             <a:off x="7351776" y="1325880"/>
-            <a:ext cx="1938528" cy="1371600"/>
+            <a:ext cx="1938528" cy="1188720"/>
           </a:xfrm>
           <a:prstGeom prst="roundRect">
             <a:avLst>
@@ -20907,8 +20907,8 @@
         </p:blipFill>
         <p:spPr>
           <a:xfrm>
-            <a:off x="8119872" y="1463040"/>
-            <a:ext cx="402336" cy="402336"/>
+            <a:off x="8138160" y="1417320"/>
+            <a:ext cx="365760" cy="365760"/>
           </a:xfrm>
           <a:prstGeom prst="rect">
             <a:avLst/>
@@ -20923,8 +20923,8 @@
         </p:nvSpPr>
         <p:spPr>
           <a:xfrm>
-            <a:off x="7351776" y="1920240"/>
-            <a:ext cx="1938528" cy="731520"/>
+            <a:off x="7351776" y="1810512"/>
+            <a:ext cx="1938528" cy="685800"/>
           </a:xfrm>
           <a:prstGeom prst="rect">
             <a:avLst/>
@@ -20978,7 +20978,7 @@
         </p:nvSpPr>
         <p:spPr>
           <a:xfrm>
-            <a:off x="9336024" y="1938528"/>
+            <a:off x="9336024" y="1847088"/>
             <a:ext cx="192024" cy="146304"/>
           </a:xfrm>
           <a:prstGeom prst="rightArrow">
@@ -21023,7 +21023,7 @@
         <p:spPr>
           <a:xfrm>
             <a:off x="9573768" y="1325880"/>
-            <a:ext cx="1938528" cy="1371600"/>
+            <a:ext cx="1938528" cy="1188720"/>
           </a:xfrm>
           <a:prstGeom prst="roundRect">
             <a:avLst>
@@ -21078,8 +21078,8 @@
         </p:blipFill>
         <p:spPr>
           <a:xfrm>
-            <a:off x="10341864" y="1463040"/>
-            <a:ext cx="402336" cy="402336"/>
+            <a:off x="10360152" y="1417320"/>
+            <a:ext cx="365760" cy="365760"/>
           </a:xfrm>
           <a:prstGeom prst="rect">
             <a:avLst/>
@@ -21094,8 +21094,8 @@
         </p:nvSpPr>
         <p:spPr>
           <a:xfrm>
-            <a:off x="9573768" y="1920240"/>
-            <a:ext cx="1938528" cy="731520"/>
+            <a:off x="9573768" y="1810512"/>
+            <a:ext cx="1938528" cy="685800"/>
           </a:xfrm>
           <a:prstGeom prst="rect">
             <a:avLst/>
@@ -21149,47 +21149,49 @@
         </p:nvSpPr>
         <p:spPr>
           <a:xfrm>
-            <a:off x="685800" y="2953512"/>
-            <a:ext cx="5340096" cy="2523744"/>
+            <a:off x="685800" y="2697480"/>
+            <a:ext cx="4846320" cy="2880360"/>
           </a:xfrm>
           <a:prstGeom prst="roundRect">
             <a:avLst>
-              <a:gd name="adj" fmla="val 4000"/>
+              <a:gd name="adj" fmla="val 6000"/>
             </a:avLst>
           </a:prstGeom>
           <a:solidFill>
-            <a:srgbClr val="FFFFFF"/>
-          </a:solidFill>
-          <a:ln>
-            <a:noFill/>
-          </a:ln>
-          <a:effectLst/>
-        </p:spPr>
-        <p:style>
-          <a:lnRef idx="1">
-            <a:schemeClr val="accent1"/>
-          </a:lnRef>
-          <a:fillRef idx="3">
-            <a:schemeClr val="accent1"/>
-          </a:fillRef>
-          <a:effectRef idx="2">
-            <a:schemeClr val="accent1"/>
-          </a:effectRef>
-          <a:fontRef idx="minor">
-            <a:schemeClr val="lt1"/>
-          </a:fontRef>
-        </p:style>
-        <p:txBody>
-          <a:bodyPr rtlCol="0" anchor="ctr"/>
-          <a:lstStyle/>
-          <a:p>
-            <a:pPr algn="ctr"/>
+            <a:srgbClr val="12223C"/>
+          </a:solidFill>
+          <a:ln w="25400">
+            <a:solidFill>
+              <a:srgbClr val="7CC4FF"/>
+            </a:solidFill>
+          </a:ln>
+          <a:effectLst/>
+        </p:spPr>
+        <p:style>
+          <a:lnRef idx="1">
+            <a:schemeClr val="accent1"/>
+          </a:lnRef>
+          <a:fillRef idx="3">
+            <a:schemeClr val="accent1"/>
+          </a:fillRef>
+          <a:effectRef idx="2">
+            <a:schemeClr val="accent1"/>
+          </a:effectRef>
+          <a:fontRef idx="minor">
+            <a:schemeClr val="lt1"/>
+          </a:fontRef>
+        </p:style>
+        <p:txBody>
+          <a:bodyPr rtlCol="0" anchor="t" wrap="square" lIns="201168" rIns="201168" tIns="109728" bIns="109728"/>
+          <a:lstStyle/>
+          <a:p>
+            <a:pPr algn="l"/>
           </a:p>
         </p:txBody>
       </p:sp>
       <p:pic>
         <p:nvPicPr>
-          <p:cNvPr id="27" name="Picture 26" descr="B1_roi_definition.png"/>
+          <p:cNvPr id="27" name="Picture 26" descr="instrument_article.png"/>
           <p:cNvPicPr>
             <a:picLocks noChangeAspect="1"/>
           </p:cNvPicPr>
@@ -21203,8 +21205,8 @@
         </p:blipFill>
         <p:spPr>
           <a:xfrm>
-            <a:off x="795528" y="3063240"/>
-            <a:ext cx="5120640" cy="2304288"/>
+            <a:off x="777240" y="2770632"/>
+            <a:ext cx="4663440" cy="2772856"/>
           </a:xfrm>
           <a:prstGeom prst="rect">
             <a:avLst/>
@@ -21219,8 +21221,8 @@
         </p:nvSpPr>
         <p:spPr>
           <a:xfrm>
-            <a:off x="685800" y="5440680"/>
-            <a:ext cx="5486400" cy="320040"/>
+            <a:off x="685800" y="5605272"/>
+            <a:ext cx="4937760" cy="457200"/>
           </a:xfrm>
           <a:prstGeom prst="rect">
             <a:avLst/>
@@ -21239,40 +21241,22 @@
               </a:spcAft>
             </a:pPr>
             <a:r>
-              <a:rPr sz="1300" b="1">
-                <a:solidFill>
-                  <a:srgbClr val="FF7A59"/>
-                </a:solidFill>
-                <a:latin typeface="Calibri"/>
-              </a:rPr>
-              <a:t>orange </a:t>
-            </a:r>
-            <a:r>
-              <a:rPr sz="1300" b="0">
+              <a:rPr sz="1100" b="1">
                 <a:solidFill>
                   <a:srgbClr val="EEF3FA"/>
                 </a:solidFill>
                 <a:latin typeface="Calibri"/>
               </a:rPr>
-              <a:t>1,030 emotion points   </a:t>
-            </a:r>
-            <a:r>
-              <a:rPr sz="1300" b="1">
+              <a:t>The live tool, one article: </a:t>
+            </a:r>
+            <a:r>
+              <a:rPr sz="1100" b="0">
                 <a:solidFill>
-                  <a:srgbClr val="7CC4FF"/>
+                  <a:srgbClr val="9AABC4"/>
                 </a:solidFill>
                 <a:latin typeface="Calibri"/>
               </a:rPr>
-              <a:t>blue </a:t>
-            </a:r>
-            <a:r>
-              <a:rPr sz="1300" b="0">
-                <a:solidFill>
-                  <a:srgbClr val="EEF3FA"/>
-                </a:solidFill>
-                <a:latin typeface="Calibri"/>
-              </a:rPr>
-              <a:t>851 reasoning points</a:t>
+              <a:t>emotion +0.109, reasoning +0.055, score +0.054, the highest in the corpus.</a:t>
             </a:r>
           </a:p>
         </p:txBody>
@@ -21285,8 +21269,8 @@
         </p:nvSpPr>
         <p:spPr>
           <a:xfrm>
-            <a:off x="6446520" y="2971800"/>
-            <a:ext cx="5056632" cy="1874519"/>
+            <a:off x="5760720" y="2697480"/>
+            <a:ext cx="5742432" cy="1783080"/>
           </a:xfrm>
           <a:prstGeom prst="roundRect">
             <a:avLst>
@@ -21333,7 +21317,7 @@
         </p:nvSpPr>
         <p:spPr>
           <a:xfrm>
-            <a:off x="6629400" y="3063240"/>
+            <a:off x="5943600" y="2770632"/>
             <a:ext cx="4572000" cy="274320"/>
           </a:xfrm>
           <a:prstGeom prst="rect">
@@ -21359,7 +21343,7 @@
                 </a:solidFill>
                 <a:latin typeface="Calibri"/>
               </a:rPr>
-              <a:t>THE SCORE</a:t>
+              <a:t>THE SCORE, X</a:t>
             </a:r>
           </a:p>
         </p:txBody>
@@ -21380,8 +21364,8 @@
         </p:blipFill>
         <p:spPr>
           <a:xfrm>
-            <a:off x="7429042" y="3383280"/>
-            <a:ext cx="3091586" cy="395020"/>
+            <a:off x="7214958" y="3017520"/>
+            <a:ext cx="2833954" cy="362102"/>
           </a:xfrm>
           <a:prstGeom prst="rect">
             <a:avLst/>
@@ -21396,8 +21380,8 @@
         </p:nvSpPr>
         <p:spPr>
           <a:xfrm>
-            <a:off x="6720840" y="4343400"/>
-            <a:ext cx="2240280" cy="91440"/>
+            <a:off x="6035040" y="3767328"/>
+            <a:ext cx="2560320" cy="91440"/>
           </a:xfrm>
           <a:prstGeom prst="rect">
             <a:avLst/>
@@ -21440,8 +21424,8 @@
         </p:nvSpPr>
         <p:spPr>
           <a:xfrm>
-            <a:off x="8988552" y="4343400"/>
-            <a:ext cx="2240280" cy="91440"/>
+            <a:off x="8622792" y="3767328"/>
+            <a:ext cx="2560320" cy="91440"/>
           </a:xfrm>
           <a:prstGeom prst="rect">
             <a:avLst/>
@@ -21484,7 +21468,7 @@
         </p:nvSpPr>
         <p:spPr>
           <a:xfrm>
-            <a:off x="8961120" y="4224528"/>
+            <a:off x="8595360" y="3648456"/>
             <a:ext cx="27432" cy="329184"/>
           </a:xfrm>
           <a:prstGeom prst="rect">
@@ -21528,8 +21512,8 @@
         </p:nvSpPr>
         <p:spPr>
           <a:xfrm>
-            <a:off x="6720840" y="4480560"/>
-            <a:ext cx="2240280" cy="274320"/>
+            <a:off x="6035040" y="3877056"/>
+            <a:ext cx="2560320" cy="274320"/>
           </a:xfrm>
           <a:prstGeom prst="rect">
             <a:avLst/>
@@ -21567,8 +21551,8 @@
         </p:nvSpPr>
         <p:spPr>
           <a:xfrm>
-            <a:off x="8988552" y="4480560"/>
-            <a:ext cx="2240280" cy="274320"/>
+            <a:off x="8622792" y="3877056"/>
+            <a:ext cx="2560320" cy="274320"/>
           </a:xfrm>
           <a:prstGeom prst="rect">
             <a:avLst/>
@@ -21606,8 +21590,8 @@
         </p:nvSpPr>
         <p:spPr>
           <a:xfrm>
-            <a:off x="8686800" y="4480560"/>
-            <a:ext cx="548640" cy="274320"/>
+            <a:off x="5943600" y="4133087"/>
+            <a:ext cx="5394960" cy="274320"/>
           </a:xfrm>
           <a:prstGeom prst="rect">
             <a:avLst/>
@@ -21626,60 +21610,144 @@
               </a:spcAft>
             </a:pPr>
             <a:r>
-              <a:rPr sz="1200" b="0" i="0">
+              <a:rPr sz="1100" b="0" i="0">
+                <a:solidFill>
+                  <a:srgbClr val="9AABC4"/>
+                </a:solidFill>
+                <a:latin typeface="Calibri"/>
+              </a:rPr>
+              <a:t>emotion areas: 1,030 points  ·  reasoning areas: 851 points  ·  nobody scanned</a:t>
+            </a:r>
+          </a:p>
+        </p:txBody>
+      </p:sp>
+      <p:sp>
+        <p:nvSpPr>
+          <p:cNvPr id="38" name="Rounded Rectangle 37">
+            <a:hlinkClick r:id="rId9"/>
+          </p:cNvPr>
+          <p:cNvSpPr/>
+          <p:nvPr/>
+        </p:nvSpPr>
+        <p:spPr>
+          <a:xfrm>
+            <a:off x="5760720" y="4617720"/>
+            <a:ext cx="5742432" cy="960120"/>
+          </a:xfrm>
+          <a:prstGeom prst="roundRect">
+            <a:avLst>
+              <a:gd name="adj" fmla="val 6000"/>
+            </a:avLst>
+          </a:prstGeom>
+          <a:solidFill>
+            <a:srgbClr val="12223C"/>
+          </a:solidFill>
+          <a:ln w="25400">
+            <a:solidFill>
+              <a:srgbClr val="F5B83D"/>
+            </a:solidFill>
+          </a:ln>
+          <a:effectLst/>
+        </p:spPr>
+        <p:style>
+          <a:lnRef idx="1">
+            <a:schemeClr val="accent1"/>
+          </a:lnRef>
+          <a:fillRef idx="3">
+            <a:schemeClr val="accent1"/>
+          </a:fillRef>
+          <a:effectRef idx="2">
+            <a:schemeClr val="accent1"/>
+          </a:effectRef>
+          <a:fontRef idx="minor">
+            <a:schemeClr val="lt1"/>
+          </a:fontRef>
+        </p:style>
+        <p:txBody>
+          <a:bodyPr rtlCol="0" anchor="t" wrap="square" lIns="201168" rIns="201168" tIns="109728" bIns="109728"/>
+          <a:lstStyle/>
+          <a:p>
+            <a:pPr algn="l"/>
+          </a:p>
+        </p:txBody>
+      </p:sp>
+      <p:pic>
+        <p:nvPicPr>
+          <p:cNvPr id="39" name="Picture 38" descr="target.png"/>
+          <p:cNvPicPr>
+            <a:picLocks noChangeAspect="1"/>
+          </p:cNvPicPr>
+          <p:nvPr/>
+        </p:nvPicPr>
+        <p:blipFill>
+          <a:blip r:embed="rId6"/>
+          <a:stretch>
+            <a:fillRect/>
+          </a:stretch>
+        </p:blipFill>
+        <p:spPr>
+          <a:xfrm>
+            <a:off x="5943600" y="4873752"/>
+            <a:ext cx="420624" cy="420624"/>
+          </a:xfrm>
+          <a:prstGeom prst="rect">
+            <a:avLst/>
+          </a:prstGeom>
+        </p:spPr>
+      </p:pic>
+      <p:sp>
+        <p:nvSpPr>
+          <p:cNvPr id="40" name="TextBox 39"/>
+          <p:cNvSpPr txBox="1"/>
+          <p:nvPr/>
+        </p:nvSpPr>
+        <p:spPr>
+          <a:xfrm>
+            <a:off x="6537960" y="4663440"/>
+            <a:ext cx="4846320" cy="914400"/>
+          </a:xfrm>
+          <a:prstGeom prst="rect">
+            <a:avLst/>
+          </a:prstGeom>
+          <a:noFill/>
+        </p:spPr>
+        <p:txBody>
+          <a:bodyPr wrap="square" anchor="ctr">
+            <a:spAutoFit/>
+          </a:bodyPr>
+          <a:lstStyle/>
+          <a:p>
+            <a:pPr algn="l">
+              <a:spcAft>
+                <a:spcPts val="0"/>
+              </a:spcAft>
+            </a:pPr>
+            <a:r>
+              <a:rPr sz="1100" b="1" i="0">
+                <a:solidFill>
+                  <a:srgbClr val="F5B83D"/>
+                </a:solidFill>
+                <a:latin typeface="Calibri"/>
+              </a:rPr>
+              <a:t>TRY THE INSTRUMENT LIVE</a:t>
+            </a:r>
+          </a:p>
+          <a:p>
+            <a:pPr algn="l">
+              <a:spcAft>
+                <a:spcPts val="0"/>
+              </a:spcAft>
+            </a:pPr>
+            <a:r>
+              <a:rPr sz="2200" b="1" i="0">
                 <a:solidFill>
                   <a:srgbClr val="EEF3FA"/>
                 </a:solidFill>
                 <a:latin typeface="Calibri"/>
               </a:rPr>
-              <a:t>0</a:t>
-            </a:r>
-          </a:p>
-        </p:txBody>
-      </p:sp>
-      <p:sp>
-        <p:nvSpPr>
-          <p:cNvPr id="38" name="Rounded Rectangle 37"/>
-          <p:cNvSpPr/>
-          <p:nvPr/>
-        </p:nvSpPr>
-        <p:spPr>
-          <a:xfrm>
-            <a:off x="6446520" y="5029200"/>
-            <a:ext cx="5056632" cy="566928"/>
-          </a:xfrm>
-          <a:prstGeom prst="roundRect">
-            <a:avLst>
-              <a:gd name="adj" fmla="val 6000"/>
-            </a:avLst>
-          </a:prstGeom>
-          <a:solidFill>
-            <a:srgbClr val="12223C"/>
-          </a:solidFill>
-          <a:ln w="25400">
-            <a:solidFill>
-              <a:srgbClr val="FF7A59"/>
-            </a:solidFill>
-          </a:ln>
-          <a:effectLst/>
-        </p:spPr>
-        <p:style>
-          <a:lnRef idx="1">
-            <a:schemeClr val="accent1"/>
-          </a:lnRef>
-          <a:fillRef idx="3">
-            <a:schemeClr val="accent1"/>
-          </a:fillRef>
-          <a:effectRef idx="2">
-            <a:schemeClr val="accent1"/>
-          </a:effectRef>
-          <a:fontRef idx="minor">
-            <a:schemeClr val="lt1"/>
-          </a:fontRef>
-        </p:style>
-        <p:txBody>
-          <a:bodyPr rtlCol="0" anchor="ctr" wrap="square" lIns="548640" rIns="201168" tIns="109728" bIns="109728"/>
-          <a:lstStyle/>
+              <a:t>monarch-4iy.pages.dev</a:t>
+            </a:r>
+          </a:p>
           <a:p>
             <a:pPr algn="l">
               <a:spcAft>
@@ -21687,44 +21755,20 @@
               </a:spcAft>
             </a:pPr>
             <a:r>
-              <a:rPr sz="1400" b="1" i="0">
+              <a:rPr sz="1100" b="0" i="0">
                 <a:solidFill>
-                  <a:srgbClr val="FF7A59"/>
+                  <a:srgbClr val="9AABC4"/>
                 </a:solidFill>
                 <a:latin typeface="Calibri"/>
               </a:rPr>
-              <a:t>Nobody scanned: every value is predicted</a:t>
-            </a:r>
-          </a:p>
-        </p:txBody>
-      </p:sp>
-      <p:pic>
-        <p:nvPicPr>
-          <p:cNvPr id="39" name="Picture 38" descr="warning.png"/>
-          <p:cNvPicPr>
-            <a:picLocks noChangeAspect="1"/>
-          </p:cNvPicPr>
-          <p:nvPr/>
-        </p:nvPicPr>
-        <p:blipFill>
-          <a:blip r:embed="rId9"/>
-          <a:stretch>
-            <a:fillRect/>
-          </a:stretch>
-        </p:blipFill>
-        <p:spPr>
-          <a:xfrm>
-            <a:off x="6611112" y="5175504"/>
-            <a:ext cx="274320" cy="274320"/>
-          </a:xfrm>
-          <a:prstGeom prst="rect">
-            <a:avLst/>
-          </a:prstGeom>
-        </p:spPr>
-      </p:pic>
-      <p:sp>
-        <p:nvSpPr>
-          <p:cNvPr id="40" name="TextBox 39"/>
+              <a:t>code and data: github.com/brn-mwai/monarch</a:t>
+            </a:r>
+          </a:p>
+        </p:txBody>
+      </p:sp>
+      <p:sp>
+        <p:nvSpPr>
+          <p:cNvPr id="41" name="TextBox 40"/>
           <p:cNvSpPr txBox="1"/>
           <p:nvPr/>
         </p:nvSpPr>
@@ -21763,7 +21807,7 @@
       </p:sp>
       <p:sp>
         <p:nvSpPr>
-          <p:cNvPr id="41" name="Rectangle 40"/>
+          <p:cNvPr id="42" name="Rectangle 41"/>
           <p:cNvSpPr/>
           <p:nvPr/>
         </p:nvSpPr>
@@ -21807,7 +21851,7 @@
       </p:sp>
       <p:sp>
         <p:nvSpPr>
-          <p:cNvPr id="42" name="Rectangle 41"/>
+          <p:cNvPr id="43" name="Rectangle 42"/>
           <p:cNvSpPr/>
           <p:nvPr/>
         </p:nvSpPr>
@@ -21851,7 +21895,7 @@
       </p:sp>
       <p:sp>
         <p:nvSpPr>
-          <p:cNvPr id="43" name="Rectangle 42"/>
+          <p:cNvPr id="44" name="Rectangle 43"/>
           <p:cNvSpPr/>
           <p:nvPr/>
         </p:nvSpPr>
@@ -21897,7 +21941,7 @@
       </p:sp>
       <p:sp>
         <p:nvSpPr>
-          <p:cNvPr id="44" name="Rectangle 43"/>
+          <p:cNvPr id="45" name="Rectangle 44"/>
           <p:cNvSpPr/>
           <p:nvPr/>
         </p:nvSpPr>
@@ -21943,7 +21987,7 @@
       </p:sp>
       <p:sp>
         <p:nvSpPr>
-          <p:cNvPr id="45" name="Rectangle 44"/>
+          <p:cNvPr id="46" name="Rectangle 45"/>
           <p:cNvSpPr/>
           <p:nvPr/>
         </p:nvSpPr>
@@ -21989,7 +22033,7 @@
       </p:sp>
       <p:sp>
         <p:nvSpPr>
-          <p:cNvPr id="46" name="TextBox 45"/>
+          <p:cNvPr id="47" name="TextBox 46"/>
           <p:cNvSpPr txBox="1"/>
           <p:nvPr/>
         </p:nvSpPr>

</xml_diff>